<commit_message>
Rapport Boulanger v3 : slide 5 met en avant la hausse de part de voix
Co-Authored-By: Claude Opus 5.5 <noreply@anthropic.com>
Claude-Session: https://claude.ai/code/session_018e7SCuQygFSJNrAfjS85j9
</commit_message>
<xml_diff>
--- a/rapports/In progress_20261009_Rapport_Boulanger_Hebdo_01.10-08.10 v3.pptx
+++ b/rapports/In progress_20261009_Rapport_Boulanger_Hebdo_01.10-08.10 v3.pptx
@@ -121,12 +121,12 @@
   <p:extLst>
     <p:ext uri="{521415D9-36F7-43E2-AB2F-B90AF26B5E84}">
       <p14:sectionLst xmlns:p14="http://schemas.microsoft.com/office/powerpoint/2010/main">
-        <p14:section name="Introduction" id="{8f2f6c36-0833-bd53-8811-640fcfb89cc4}">
+        <p14:section name="Introduction" id="{53f8976a-43c0-d7b1-2bb5-7f0e424d3f5b}">
           <p14:sldIdLst>
             <p14:sldId id="256"/>
           </p14:sldIdLst>
         </p14:section>
-        <p14:section name="Boulanger" id="{c168c988-01ab-5299-45d2-c58651aba97a}">
+        <p14:section name="Boulanger" id="{d9fcc402-7458-0afe-daa5-57673f62f80b}">
           <p14:sldIdLst>
             <p14:sldId id="257"/>
             <p14:sldId id="258"/>
@@ -140,7 +140,7 @@
             <p14:sldId id="266"/>
           </p14:sldIdLst>
         </p14:section>
-        <p14:section name="Pistes de reco" id="{6c2e2556-c8d7-e407-5394-66debcabae24}">
+        <p14:section name="Pistes de reco" id="{8a68f3da-ea66-1a6f-2747-165051e7c9e6}">
           <p14:sldIdLst>
             <p14:sldId id="267"/>
             <p14:sldId id="268"/>
@@ -460,7 +460,7 @@
         <c:axId val="2094734552"/>
         <c:scaling>
           <c:orientation val="minMax"/>
-          <c:max val="18"/>
+          <c:max val="20"/>
           <c:min val="0"/>
         </c:scaling>
         <c:delete val="1"/>
@@ -11518,7 +11518,7 @@
                   <a:schemeClr val="tx1"/>
                 </a:solidFill>
               </a:rPr>
-              <a:t>Boulanger gagne 2,5 points de part de voix dans les réponses de l'IA</a:t>
+              <a:t>Part de voix en hausse : +2,5 points (+47 %) en une semaine</a:t>
             </a:r>
             <a:endParaRPr lang="en-US" sz="3000" dirty="0"/>
           </a:p>
@@ -13416,7 +13416,7 @@
         <p:spPr>
           <a:xfrm>
             <a:off x="6812280" y="2468880"/>
-            <a:ext cx="4572000" cy="274320"/>
+            <a:ext cx="2560320" cy="274320"/>
           </a:xfrm>
           <a:prstGeom prst="rect">
             <a:avLst/>
@@ -13437,7 +13437,7 @@
                   <a:srgbClr val="5A6275"/>
                 </a:solidFill>
               </a:rPr>
-              <a:t>% des citations dans les réponses de l'agent (GEO)</a:t>
+              <a:t>% des citations (GEO)</a:t>
             </a:r>
             <a:endParaRPr lang="en-US" sz="1100" dirty="0"/>
           </a:p>
@@ -13461,7 +13461,84 @@
       </p:graphicFrame>
       <p:sp>
         <p:nvSpPr>
-          <p:cNvPr id="63" name="Text 60"/>
+          <p:cNvPr id="63" name="Shape 60"/>
+          <p:cNvSpPr/>
+          <p:nvPr/>
+        </p:nvSpPr>
+        <p:spPr>
+          <a:xfrm>
+            <a:off x="9464040" y="2103120"/>
+            <a:ext cx="1965960" cy="566928"/>
+          </a:xfrm>
+          <a:prstGeom prst="roundRect">
+            <a:avLst>
+              <a:gd name="adj" fmla="val 16129"/>
+            </a:avLst>
+          </a:prstGeom>
+          <a:solidFill>
+            <a:srgbClr val="E7F4EC"/>
+          </a:solidFill>
+          <a:ln w="12700">
+            <a:solidFill>
+              <a:srgbClr val="2E9E6B"/>
+            </a:solidFill>
+            <a:prstDash val="solid"/>
+          </a:ln>
+        </p:spPr>
+      </p:sp>
+      <p:sp>
+        <p:nvSpPr>
+          <p:cNvPr id="64" name="Text 61"/>
+          <p:cNvSpPr txBox="1"/>
+          <p:nvPr/>
+        </p:nvSpPr>
+        <p:spPr>
+          <a:xfrm>
+            <a:off x="9464040" y="2103120"/>
+            <a:ext cx="1965960" cy="566928"/>
+          </a:xfrm>
+          <a:prstGeom prst="rect">
+            <a:avLst/>
+          </a:prstGeom>
+          <a:noFill/>
+          <a:ln/>
+        </p:spPr>
+        <p:txBody>
+          <a:bodyPr wrap="square" lIns="0" tIns="0" rIns="0" bIns="0" rtlCol="0" anchor="ctr"/>
+          <a:lstStyle/>
+          <a:p>
+            <a:pPr algn="ctr" indent="0" marL="0">
+              <a:buNone/>
+            </a:pPr>
+            <a:r>
+              <a:rPr lang="en-US" sz="1600" b="1" dirty="0">
+                <a:solidFill>
+                  <a:srgbClr val="2E9E6B"/>
+                </a:solidFill>
+              </a:rPr>
+              <a:t>▲ +2,5 pts</a:t>
+            </a:r>
+            <a:endParaRPr lang="en-US" sz="1600" dirty="0"/>
+          </a:p>
+          <a:p>
+            <a:pPr algn="ctr" indent="0" marL="0">
+              <a:buNone/>
+            </a:pPr>
+            <a:r>
+              <a:rPr lang="en-US" sz="1000" b="1" dirty="0">
+                <a:solidFill>
+                  <a:srgbClr val="2E9E6B"/>
+                </a:solidFill>
+              </a:rPr>
+              <a:t>+47 % vs S-1</a:t>
+            </a:r>
+            <a:endParaRPr lang="en-US" sz="1600" dirty="0"/>
+          </a:p>
+        </p:txBody>
+      </p:sp>
+      <p:sp>
+        <p:nvSpPr>
+          <p:cNvPr id="65" name="Text 62"/>
           <p:cNvSpPr txBox="1"/>
           <p:nvPr/>
         </p:nvSpPr>

</xml_diff>